<commit_message>
Talk: point the closing slide at the renamed fork, karlglazebrook/ADASS2026
</commit_message>
<xml_diff>
--- a/ADASS2026/talk/ADASS2026-talk.pptx
+++ b/ADASS2026/talk/ADASS2026-talk.pptx
@@ -122,7 +122,7 @@
   <p:extLst>
     <p:ext uri="{521415D9-36F7-43E2-AB2F-B90AF26B5E84}">
       <p14:sectionLst xmlns:p14="http://schemas.microsoft.com/office/powerpoint/2010/main">
-        <p14:section name="The story" id="{198e1499-e8c7-b9f6-8d7e-6583d90842cf}">
+        <p14:section name="The story" id="{05829267-b16f-0d5d-8959-790587f3054f}">
           <p14:sldIdLst>
             <p14:sldId id="256"/>
             <p14:sldId id="257"/>
@@ -130,7 +130,7 @@
             <p14:sldId id="259"/>
           </p14:sldIdLst>
         </p14:section>
-        <p14:section name="Results" id="{ee50cc5a-7f17-bb66-fae7-3a082aae614b}">
+        <p14:section name="Results" id="{5a551a56-26c8-7415-f9ad-57be84ba6cc7}">
           <p14:sldIdLst>
             <p14:sldId id="260"/>
             <p14:sldId id="261"/>
@@ -139,7 +139,7 @@
             <p14:sldId id="264"/>
           </p14:sldIdLst>
         </p14:section>
-        <p14:section name="The LLM" id="{f9b5c278-2d5e-6c15-2994-38cefc29d9ae}">
+        <p14:section name="The LLM" id="{ff123a03-4675-7593-cc04-2939585069ab}">
           <p14:sldIdLst>
             <p14:sldId id="265"/>
             <p14:sldId id="266"/>
@@ -147,7 +147,7 @@
             <p14:sldId id="268"/>
           </p14:sldIdLst>
         </p14:section>
-        <p14:section name="Backup" id="{3d4b2168-5936-3e0d-8e36-0b7ae0729478}">
+        <p14:section name="Backup" id="{62da8ec1-fad2-ab01-6975-06c099435b4f}">
           <p14:sldIdLst>
             <p14:sldId id="269"/>
             <p14:sldId id="270"/>
@@ -9733,7 +9733,7 @@
                   </a:extLst>
                 </a:hlinkClick>
               </a:rPr>
-              <a:t>github.com/karlglazebrook/ADASS2019</a:t>
+              <a:t>github.com/karlglazebrook/ADASS2026</a:t>
             </a:r>
             <a:endParaRPr lang="en-US" sz="2000" dirty="0"/>
           </a:p>

</xml_diff>